<commit_message>
Redo Boeing 737 MAX poster as A1 portrait and stop photos stretching
Rebuilt the slide at 594 x 841 mm with a 2x2 panel layout. Photos are
now pre-cropped to their frame's exact shape, so Google Slides cannot
stretch the header image.

Co-Authored-By: Claude Opus 5.5 <noreply@anthropic.com>
Claude-Session: https://claude.ai/code/session_01E3rJRgKZxEHSV1mKDFw6wE
</commit_message>
<xml_diff>
--- a/boeing-737-max-example/Poster - Boeing 737 MAX.pptx
+++ b/boeing-737-max-example/Poster - Boeing 737 MAX.pptx
@@ -10,8 +10,8 @@
   <p:notesMasterIdLst>
     <p:notesMasterId r:id="rId3"/>
   </p:notesMasterIdLst>
-  <p:sldSz cx="30275784" cy="21387816"/>
-  <p:notesSz cx="21387816" cy="30275784"/>
+  <p:sldSz cx="21384158" cy="30275784"/>
+  <p:notesSz cx="30275784" cy="21384158"/>
   <p:defaultTextStyle>
     <a:lvl1pPr marL="0" algn="l" defTabSz="914400" rtl="0" eaLnBrk="1" latinLnBrk="0" hangingPunct="1">
       <a:defRPr sz="1800" kern="1200">
@@ -107,7 +107,7 @@
   <p:extLst>
     <p:ext uri="{521415D9-36F7-43E2-AB2F-B90AF26B5E84}">
       <p14:sectionLst xmlns:p14="http://schemas.microsoft.com/office/powerpoint/2010/main">
-        <p14:section name="Poster" id="{b2fd579c-fa7c-2b94-9423-b7ae9d011fd1}">
+        <p14:section name="Poster" id="{d3cd71f6-31c9-5f70-99b7-27f91fd87482}">
           <p14:sldIdLst>
             <p14:sldId id="256"/>
           </p14:sldIdLst>
@@ -147,7 +147,7 @@
                 </a:solidFill>
                 <a:latin typeface="+mn-lt"/>
               </a:rPr>
-              <a:t>MCAS nose-down trim per activation (degrees)</a:t>
+              <a:t>MCAS nose-down trim per activation (°)</a:t>
             </a:r>
           </a:p>
         </c:rich>
@@ -316,7 +316,7 @@
           <a:lstStyle/>
           <a:p>
             <a:pPr>
-              <a:defRPr sz="1500" b="0" i="0" u="none" strike="noStrike">
+              <a:defRPr sz="1400" b="0" i="0" u="none" strike="noStrike">
                 <a:solidFill>
                   <a:srgbClr val="2E3A48"/>
                 </a:solidFill>
@@ -1201,13 +1201,14 @@
         </p:nvPicPr>
         <p:blipFill>
           <a:blip r:embed="rId1"/>
-          <a:srcRect l="0" r="0" t="0" b="0"/>
-          <a:stretch/>
+          <a:stretch>
+            <a:fillRect/>
+          </a:stretch>
         </p:blipFill>
         <p:spPr>
           <a:xfrm>
             <a:off x="0" y="0"/>
-            <a:ext cx="30275784" cy="4480560"/>
+            <a:ext cx="21384158" cy="5760720"/>
           </a:xfrm>
           <a:prstGeom prst="rect">
             <a:avLst/>
@@ -1223,14 +1224,14 @@
         <p:spPr>
           <a:xfrm>
             <a:off x="0" y="0"/>
-            <a:ext cx="30275784" cy="4480560"/>
+            <a:ext cx="21384158" cy="5760720"/>
           </a:xfrm>
           <a:prstGeom prst="rect">
             <a:avLst/>
           </a:prstGeom>
           <a:solidFill>
             <a:schemeClr val="tx1">
-              <a:alpha val="68000"/>
+              <a:alpha val="70000"/>
             </a:schemeClr>
           </a:solidFill>
           <a:ln/>
@@ -1244,8 +1245,8 @@
         </p:nvSpPr>
         <p:spPr>
           <a:xfrm>
-            <a:off x="731520" y="457200"/>
-            <a:ext cx="18288000" cy="411480"/>
+            <a:off x="731520" y="685800"/>
+            <a:ext cx="14630400" cy="411480"/>
           </a:xfrm>
           <a:prstGeom prst="rect">
             <a:avLst/>
@@ -1280,8 +1281,8 @@
         </p:nvSpPr>
         <p:spPr>
           <a:xfrm>
-            <a:off x="731520" y="914400"/>
-            <a:ext cx="21945600" cy="1417320"/>
+            <a:off x="731520" y="1234440"/>
+            <a:ext cx="15544800" cy="1463040"/>
           </a:xfrm>
           <a:prstGeom prst="rect">
             <a:avLst/>
@@ -1316,8 +1317,8 @@
         </p:nvSpPr>
         <p:spPr>
           <a:xfrm>
-            <a:off x="731520" y="2377440"/>
-            <a:ext cx="21945600" cy="914400"/>
+            <a:off x="731520" y="2743200"/>
+            <a:ext cx="15544800" cy="914400"/>
           </a:xfrm>
           <a:prstGeom prst="rect">
             <a:avLst/>
@@ -1352,8 +1353,8 @@
         </p:nvSpPr>
         <p:spPr>
           <a:xfrm>
-            <a:off x="731520" y="3520440"/>
-            <a:ext cx="21945600" cy="457200"/>
+            <a:off x="731520" y="4160520"/>
+            <a:ext cx="15544800" cy="457200"/>
           </a:xfrm>
           <a:prstGeom prst="rect">
             <a:avLst/>
@@ -1369,14 +1370,14 @@
               <a:buNone/>
             </a:pPr>
             <a:r>
-              <a:rPr lang="en-US" sz="2600" dirty="0">
+              <a:rPr lang="en-US" sz="2400" dirty="0">
                 <a:solidFill>
                   <a:schemeClr val="bg1"/>
                 </a:solidFill>
               </a:rPr>
               <a:t>[Your Name]  ·  4th Year Software Development Student, SETU  ·  October 2026</a:t>
             </a:r>
-            <a:endParaRPr lang="en-US" sz="2600" dirty="0"/>
+            <a:endParaRPr lang="en-US" sz="2400" dirty="0"/>
           </a:p>
         </p:txBody>
       </p:sp>
@@ -1388,8 +1389,8 @@
         </p:nvSpPr>
         <p:spPr>
           <a:xfrm>
-            <a:off x="25795224" y="365760"/>
-            <a:ext cx="3749040" cy="3749040"/>
+            <a:off x="16720718" y="914400"/>
+            <a:ext cx="3931920" cy="3931920"/>
           </a:xfrm>
           <a:prstGeom prst="ellipse">
             <a:avLst/>
@@ -1420,8 +1421,8 @@
         </p:nvSpPr>
         <p:spPr>
           <a:xfrm>
-            <a:off x="25795224" y="1051560"/>
-            <a:ext cx="3749040" cy="1463040"/>
+            <a:off x="16720718" y="1645920"/>
+            <a:ext cx="3931920" cy="1463040"/>
           </a:xfrm>
           <a:prstGeom prst="rect">
             <a:avLst/>
@@ -1437,14 +1438,14 @@
               <a:buNone/>
             </a:pPr>
             <a:r>
-              <a:rPr lang="en-US" sz="11000" b="1" dirty="0">
+              <a:rPr lang="en-US" sz="11200" b="1" dirty="0">
                 <a:solidFill>
                   <a:schemeClr val="bg1"/>
                 </a:solidFill>
               </a:rPr>
               <a:t>346</a:t>
             </a:r>
-            <a:endParaRPr lang="en-US" sz="11000" dirty="0"/>
+            <a:endParaRPr lang="en-US" sz="11200" dirty="0"/>
           </a:p>
         </p:txBody>
       </p:sp>
@@ -1456,8 +1457,8 @@
         </p:nvSpPr>
         <p:spPr>
           <a:xfrm>
-            <a:off x="25795224" y="2606040"/>
-            <a:ext cx="3749040" cy="548640"/>
+            <a:off x="16720718" y="3246120"/>
+            <a:ext cx="3931920" cy="548640"/>
           </a:xfrm>
           <a:prstGeom prst="rect">
             <a:avLst/>
@@ -1492,12 +1493,12 @@
         </p:nvSpPr>
         <p:spPr>
           <a:xfrm>
-            <a:off x="731520" y="4892040"/>
-            <a:ext cx="6860286" cy="14721840"/>
+            <a:off x="731520" y="6217920"/>
+            <a:ext cx="9731959" cy="10789920"/>
           </a:xfrm>
           <a:prstGeom prst="roundRect">
             <a:avLst>
-              <a:gd name="adj" fmla="val 3999"/>
+              <a:gd name="adj" fmla="val 2819"/>
             </a:avLst>
           </a:prstGeom>
           <a:solidFill>
@@ -1521,7 +1522,7 @@
         </p:nvSpPr>
         <p:spPr>
           <a:xfrm>
-            <a:off x="1097280" y="5257800"/>
+            <a:off x="1097280" y="6583680"/>
             <a:ext cx="1051560" cy="1051560"/>
           </a:xfrm>
           <a:prstGeom prst="ellipse">
@@ -1541,7 +1542,7 @@
         </p:nvSpPr>
         <p:spPr>
           <a:xfrm>
-            <a:off x="1097280" y="5257800"/>
+            <a:off x="1097280" y="6583680"/>
             <a:ext cx="1051560" cy="1051560"/>
           </a:xfrm>
           <a:prstGeom prst="rect">
@@ -1577,8 +1578,8 @@
         </p:nvSpPr>
         <p:spPr>
           <a:xfrm>
-            <a:off x="2377440" y="5212080"/>
-            <a:ext cx="4848606" cy="1143000"/>
+            <a:off x="2423160" y="6537960"/>
+            <a:ext cx="7674559" cy="1143000"/>
           </a:xfrm>
           <a:prstGeom prst="rect">
             <a:avLst/>
@@ -1594,14 +1595,14 @@
               <a:buNone/>
             </a:pPr>
             <a:r>
-              <a:rPr lang="en-US" sz="3200" b="1" dirty="0">
+              <a:rPr lang="en-US" sz="3600" b="1" dirty="0">
                 <a:solidFill>
                   <a:schemeClr val="tx1"/>
                 </a:solidFill>
               </a:rPr>
               <a:t>What happened?</a:t>
             </a:r>
-            <a:endParaRPr lang="en-US" sz="3200" dirty="0"/>
+            <a:endParaRPr lang="en-US" sz="3600" dirty="0"/>
           </a:p>
         </p:txBody>
       </p:sp>
@@ -1613,12 +1614,12 @@
         </p:nvSpPr>
         <p:spPr>
           <a:xfrm>
-            <a:off x="8049006" y="4892040"/>
-            <a:ext cx="6860286" cy="14721840"/>
+            <a:off x="10920679" y="6217920"/>
+            <a:ext cx="9731959" cy="10789920"/>
           </a:xfrm>
           <a:prstGeom prst="roundRect">
             <a:avLst>
-              <a:gd name="adj" fmla="val 3999"/>
+              <a:gd name="adj" fmla="val 2819"/>
             </a:avLst>
           </a:prstGeom>
           <a:solidFill>
@@ -1642,7 +1643,7 @@
         </p:nvSpPr>
         <p:spPr>
           <a:xfrm>
-            <a:off x="8414766" y="5257800"/>
+            <a:off x="11286439" y="6583680"/>
             <a:ext cx="1051560" cy="1051560"/>
           </a:xfrm>
           <a:prstGeom prst="ellipse">
@@ -1662,7 +1663,7 @@
         </p:nvSpPr>
         <p:spPr>
           <a:xfrm>
-            <a:off x="8414766" y="5257800"/>
+            <a:off x="11286439" y="6583680"/>
             <a:ext cx="1051560" cy="1051560"/>
           </a:xfrm>
           <a:prstGeom prst="rect">
@@ -1698,8 +1699,8 @@
         </p:nvSpPr>
         <p:spPr>
           <a:xfrm>
-            <a:off x="9694926" y="5212080"/>
-            <a:ext cx="4848606" cy="1143000"/>
+            <a:off x="12612319" y="6537960"/>
+            <a:ext cx="7674559" cy="1143000"/>
           </a:xfrm>
           <a:prstGeom prst="rect">
             <a:avLst/>
@@ -1715,14 +1716,14 @@
               <a:buNone/>
             </a:pPr>
             <a:r>
-              <a:rPr lang="en-US" sz="3200" b="1" dirty="0">
+              <a:rPr lang="en-US" sz="3600" b="1" dirty="0">
                 <a:solidFill>
                   <a:schemeClr val="tx1"/>
                 </a:solidFill>
               </a:rPr>
               <a:t>The hidden software: MCAS</a:t>
             </a:r>
-            <a:endParaRPr lang="en-US" sz="3200" dirty="0"/>
+            <a:endParaRPr lang="en-US" sz="3600" dirty="0"/>
           </a:p>
         </p:txBody>
       </p:sp>
@@ -1734,12 +1735,12 @@
         </p:nvSpPr>
         <p:spPr>
           <a:xfrm>
-            <a:off x="15366492" y="4892040"/>
-            <a:ext cx="6860286" cy="14721840"/>
+            <a:off x="731520" y="17465040"/>
+            <a:ext cx="9731959" cy="10789920"/>
           </a:xfrm>
           <a:prstGeom prst="roundRect">
             <a:avLst>
-              <a:gd name="adj" fmla="val 3999"/>
+              <a:gd name="adj" fmla="val 2819"/>
             </a:avLst>
           </a:prstGeom>
           <a:solidFill>
@@ -1763,7 +1764,7 @@
         </p:nvSpPr>
         <p:spPr>
           <a:xfrm>
-            <a:off x="15732252" y="5257800"/>
+            <a:off x="1097280" y="17830800"/>
             <a:ext cx="1051560" cy="1051560"/>
           </a:xfrm>
           <a:prstGeom prst="ellipse">
@@ -1783,7 +1784,7 @@
         </p:nvSpPr>
         <p:spPr>
           <a:xfrm>
-            <a:off x="15732252" y="5257800"/>
+            <a:off x="1097280" y="17830800"/>
             <a:ext cx="1051560" cy="1051560"/>
           </a:xfrm>
           <a:prstGeom prst="rect">
@@ -1819,8 +1820,8 @@
         </p:nvSpPr>
         <p:spPr>
           <a:xfrm>
-            <a:off x="17012412" y="5212080"/>
-            <a:ext cx="4848606" cy="1143000"/>
+            <a:off x="2423160" y="17785080"/>
+            <a:ext cx="7674559" cy="1143000"/>
           </a:xfrm>
           <a:prstGeom prst="rect">
             <a:avLst/>
@@ -1836,14 +1837,14 @@
               <a:buNone/>
             </a:pPr>
             <a:r>
-              <a:rPr lang="en-US" sz="3200" b="1" dirty="0">
+              <a:rPr lang="en-US" sz="3600" b="1" dirty="0">
                 <a:solidFill>
                   <a:schemeClr val="tx1"/>
                 </a:solidFill>
               </a:rPr>
               <a:t>Bug or business decision?</a:t>
             </a:r>
-            <a:endParaRPr lang="en-US" sz="3200" dirty="0"/>
+            <a:endParaRPr lang="en-US" sz="3600" dirty="0"/>
           </a:p>
         </p:txBody>
       </p:sp>
@@ -1855,12 +1856,12 @@
         </p:nvSpPr>
         <p:spPr>
           <a:xfrm>
-            <a:off x="22683978" y="4892040"/>
-            <a:ext cx="6860286" cy="14721840"/>
+            <a:off x="10920679" y="17465040"/>
+            <a:ext cx="9731959" cy="10789920"/>
           </a:xfrm>
           <a:prstGeom prst="roundRect">
             <a:avLst>
-              <a:gd name="adj" fmla="val 3999"/>
+              <a:gd name="adj" fmla="val 2819"/>
             </a:avLst>
           </a:prstGeom>
           <a:solidFill>
@@ -1884,7 +1885,7 @@
         </p:nvSpPr>
         <p:spPr>
           <a:xfrm>
-            <a:off x="23049738" y="5257800"/>
+            <a:off x="11286439" y="17830800"/>
             <a:ext cx="1051560" cy="1051560"/>
           </a:xfrm>
           <a:prstGeom prst="ellipse">
@@ -1904,7 +1905,7 @@
         </p:nvSpPr>
         <p:spPr>
           <a:xfrm>
-            <a:off x="23049738" y="5257800"/>
+            <a:off x="11286439" y="17830800"/>
             <a:ext cx="1051560" cy="1051560"/>
           </a:xfrm>
           <a:prstGeom prst="rect">
@@ -1940,8 +1941,8 @@
         </p:nvSpPr>
         <p:spPr>
           <a:xfrm>
-            <a:off x="24329898" y="5212080"/>
-            <a:ext cx="4848606" cy="1143000"/>
+            <a:off x="12612319" y="17785080"/>
+            <a:ext cx="7674559" cy="1143000"/>
           </a:xfrm>
           <a:prstGeom prst="rect">
             <a:avLst/>
@@ -1957,14 +1958,14 @@
               <a:buNone/>
             </a:pPr>
             <a:r>
-              <a:rPr lang="en-US" sz="3200" b="1" dirty="0">
+              <a:rPr lang="en-US" sz="3600" b="1" dirty="0">
                 <a:solidFill>
                   <a:schemeClr val="tx1"/>
                 </a:solidFill>
               </a:rPr>
               <a:t>What should developers learn?</a:t>
             </a:r>
-            <a:endParaRPr lang="en-US" sz="3200" dirty="0"/>
+            <a:endParaRPr lang="en-US" sz="3600" dirty="0"/>
           </a:p>
         </p:txBody>
       </p:sp>
@@ -1976,8 +1977,8 @@
         </p:nvSpPr>
         <p:spPr>
           <a:xfrm>
-            <a:off x="1097280" y="6675120"/>
-            <a:ext cx="6128766" cy="1234440"/>
+            <a:off x="1097280" y="8001000"/>
+            <a:ext cx="9000439" cy="868680"/>
           </a:xfrm>
           <a:prstGeom prst="rect">
             <a:avLst/>
@@ -1993,7 +1994,7 @@
               <a:buNone/>
             </a:pPr>
             <a:r>
-              <a:rPr lang="en-US" sz="2400" dirty="0">
+              <a:rPr lang="en-US" sz="2500" dirty="0">
                 <a:solidFill>
                   <a:schemeClr val="tx2"/>
                 </a:solidFill>
@@ -2004,7 +2005,7 @@
               <a:buNone/>
             </a:pPr>
             <a:r>
-              <a:rPr lang="en-US" sz="2400" b="1" dirty="0">
+              <a:rPr lang="en-US" sz="2500" b="1" dirty="0">
                 <a:solidFill>
                   <a:schemeClr val="tx2"/>
                 </a:solidFill>
@@ -2015,7 +2016,7 @@
               <a:buNone/>
             </a:pPr>
             <a:r>
-              <a:rPr lang="en-US" sz="2400" dirty="0">
+              <a:rPr lang="en-US" sz="2500" dirty="0">
                 <a:solidFill>
                   <a:schemeClr val="tx2"/>
                 </a:solidFill>
@@ -2026,14 +2027,14 @@
               <a:buNone/>
             </a:pPr>
             <a:r>
-              <a:rPr lang="en-US" sz="2400" b="1" dirty="0">
+              <a:rPr lang="en-US" sz="2500" b="1" dirty="0">
                 <a:solidFill>
                   <a:schemeClr val="tx2"/>
                 </a:solidFill>
               </a:rPr>
               <a:t>less than five months apart.</a:t>
             </a:r>
-            <a:endParaRPr lang="en-US" sz="2400" dirty="0"/>
+            <a:endParaRPr lang="en-US" sz="2500" dirty="0"/>
           </a:p>
         </p:txBody>
       </p:sp>
@@ -2045,8 +2046,8 @@
         </p:nvSpPr>
         <p:spPr>
           <a:xfrm>
-            <a:off x="1298448" y="8430768"/>
-            <a:ext cx="0" cy="6291072"/>
+            <a:off x="1298448" y="9390888"/>
+            <a:ext cx="0" cy="4754880"/>
           </a:xfrm>
           <a:prstGeom prst="line">
             <a:avLst/>
@@ -2068,7 +2069,7 @@
         </p:nvSpPr>
         <p:spPr>
           <a:xfrm>
-            <a:off x="1097280" y="8229600"/>
+            <a:off x="1097280" y="9189720"/>
             <a:ext cx="402336" cy="402336"/>
           </a:xfrm>
           <a:prstGeom prst="ellipse">
@@ -2093,8 +2094,8 @@
         </p:nvSpPr>
         <p:spPr>
           <a:xfrm>
-            <a:off x="1828800" y="8183880"/>
-            <a:ext cx="5397246" cy="457200"/>
+            <a:off x="1828800" y="9144000"/>
+            <a:ext cx="8268919" cy="457200"/>
           </a:xfrm>
           <a:prstGeom prst="rect">
             <a:avLst/>
@@ -2129,8 +2130,8 @@
         </p:nvSpPr>
         <p:spPr>
           <a:xfrm>
-            <a:off x="1828800" y="8686800"/>
-            <a:ext cx="5397246" cy="914400"/>
+            <a:off x="1828800" y="9628632"/>
+            <a:ext cx="8268919" cy="457200"/>
           </a:xfrm>
           <a:prstGeom prst="rect">
             <a:avLst/>
@@ -2146,14 +2147,14 @@
               <a:buNone/>
             </a:pPr>
             <a:r>
-              <a:rPr lang="en-US" sz="2100" dirty="0">
+              <a:rPr lang="en-US" sz="2200" dirty="0">
                 <a:solidFill>
                   <a:schemeClr val="tx2"/>
                 </a:solidFill>
               </a:rPr>
               <a:t>Lion Air 610, Indonesia: 189 killed [4]</a:t>
             </a:r>
-            <a:endParaRPr lang="en-US" sz="2100" dirty="0"/>
+            <a:endParaRPr lang="en-US" sz="2200" dirty="0"/>
           </a:p>
         </p:txBody>
       </p:sp>
@@ -2165,7 +2166,7 @@
         </p:nvSpPr>
         <p:spPr>
           <a:xfrm>
-            <a:off x="1097280" y="9802368"/>
+            <a:off x="1097280" y="10378440"/>
             <a:ext cx="402336" cy="402336"/>
           </a:xfrm>
           <a:prstGeom prst="ellipse">
@@ -2190,8 +2191,8 @@
         </p:nvSpPr>
         <p:spPr>
           <a:xfrm>
-            <a:off x="1828800" y="9756648"/>
-            <a:ext cx="5397246" cy="457200"/>
+            <a:off x="1828800" y="10332720"/>
+            <a:ext cx="8268919" cy="457200"/>
           </a:xfrm>
           <a:prstGeom prst="rect">
             <a:avLst/>
@@ -2226,8 +2227,8 @@
         </p:nvSpPr>
         <p:spPr>
           <a:xfrm>
-            <a:off x="1828800" y="10259568"/>
-            <a:ext cx="5397246" cy="914400"/>
+            <a:off x="1828800" y="10817352"/>
+            <a:ext cx="8268919" cy="457200"/>
           </a:xfrm>
           <a:prstGeom prst="rect">
             <a:avLst/>
@@ -2243,14 +2244,14 @@
               <a:buNone/>
             </a:pPr>
             <a:r>
-              <a:rPr lang="en-US" sz="2100" dirty="0">
+              <a:rPr lang="en-US" sz="2200" dirty="0">
                 <a:solidFill>
                   <a:schemeClr val="tx2"/>
                 </a:solidFill>
               </a:rPr>
               <a:t>Ethiopian Airlines 302: 157 killed [4]</a:t>
             </a:r>
-            <a:endParaRPr lang="en-US" sz="2100" dirty="0"/>
+            <a:endParaRPr lang="en-US" sz="2200" dirty="0"/>
           </a:p>
         </p:txBody>
       </p:sp>
@@ -2262,7 +2263,7 @@
         </p:nvSpPr>
         <p:spPr>
           <a:xfrm>
-            <a:off x="1097280" y="11375136"/>
+            <a:off x="1097280" y="11567160"/>
             <a:ext cx="402336" cy="402336"/>
           </a:xfrm>
           <a:prstGeom prst="ellipse">
@@ -2287,8 +2288,8 @@
         </p:nvSpPr>
         <p:spPr>
           <a:xfrm>
-            <a:off x="1828800" y="11329416"/>
-            <a:ext cx="5397246" cy="457200"/>
+            <a:off x="1828800" y="11521440"/>
+            <a:ext cx="8268919" cy="457200"/>
           </a:xfrm>
           <a:prstGeom prst="rect">
             <a:avLst/>
@@ -2323,8 +2324,8 @@
         </p:nvSpPr>
         <p:spPr>
           <a:xfrm>
-            <a:off x="1828800" y="11832336"/>
-            <a:ext cx="5397246" cy="914400"/>
+            <a:off x="1828800" y="12006072"/>
+            <a:ext cx="8268919" cy="457200"/>
           </a:xfrm>
           <a:prstGeom prst="rect">
             <a:avLst/>
@@ -2340,14 +2341,14 @@
               <a:buNone/>
             </a:pPr>
             <a:r>
-              <a:rPr lang="en-US" sz="2100" dirty="0">
+              <a:rPr lang="en-US" sz="2200" dirty="0">
                 <a:solidFill>
                   <a:schemeClr val="tx2"/>
                 </a:solidFill>
               </a:rPr>
               <a:t>The FAA grounds the 737 MAX in the US [4]</a:t>
             </a:r>
-            <a:endParaRPr lang="en-US" sz="2100" dirty="0"/>
+            <a:endParaRPr lang="en-US" sz="2200" dirty="0"/>
           </a:p>
         </p:txBody>
       </p:sp>
@@ -2359,7 +2360,7 @@
         </p:nvSpPr>
         <p:spPr>
           <a:xfrm>
-            <a:off x="1097280" y="12947904"/>
+            <a:off x="1097280" y="12755880"/>
             <a:ext cx="402336" cy="402336"/>
           </a:xfrm>
           <a:prstGeom prst="ellipse">
@@ -2384,8 +2385,8 @@
         </p:nvSpPr>
         <p:spPr>
           <a:xfrm>
-            <a:off x="1828800" y="12902184"/>
-            <a:ext cx="5397246" cy="457200"/>
+            <a:off x="1828800" y="12710160"/>
+            <a:ext cx="8268919" cy="457200"/>
           </a:xfrm>
           <a:prstGeom prst="rect">
             <a:avLst/>
@@ -2420,8 +2421,8 @@
         </p:nvSpPr>
         <p:spPr>
           <a:xfrm>
-            <a:off x="1828800" y="13405104"/>
-            <a:ext cx="5397246" cy="914400"/>
+            <a:off x="1828800" y="13194792"/>
+            <a:ext cx="8268919" cy="457200"/>
           </a:xfrm>
           <a:prstGeom prst="rect">
             <a:avLst/>
@@ -2437,14 +2438,14 @@
               <a:buNone/>
             </a:pPr>
             <a:r>
-              <a:rPr lang="en-US" sz="2100" dirty="0">
+              <a:rPr lang="en-US" sz="2200" dirty="0">
                 <a:solidFill>
                   <a:schemeClr val="tx2"/>
                 </a:solidFill>
               </a:rPr>
               <a:t>Cleared to fly again after a software fix [4]</a:t>
             </a:r>
-            <a:endParaRPr lang="en-US" sz="2100" dirty="0"/>
+            <a:endParaRPr lang="en-US" sz="2200" dirty="0"/>
           </a:p>
         </p:txBody>
       </p:sp>
@@ -2456,7 +2457,7 @@
         </p:nvSpPr>
         <p:spPr>
           <a:xfrm>
-            <a:off x="1097280" y="14520672"/>
+            <a:off x="1097280" y="13944600"/>
             <a:ext cx="402336" cy="402336"/>
           </a:xfrm>
           <a:prstGeom prst="ellipse">
@@ -2481,8 +2482,8 @@
         </p:nvSpPr>
         <p:spPr>
           <a:xfrm>
-            <a:off x="1828800" y="14474952"/>
-            <a:ext cx="5397246" cy="457200"/>
+            <a:off x="1828800" y="13898880"/>
+            <a:ext cx="8268919" cy="457200"/>
           </a:xfrm>
           <a:prstGeom prst="rect">
             <a:avLst/>
@@ -2517,8 +2518,8 @@
         </p:nvSpPr>
         <p:spPr>
           <a:xfrm>
-            <a:off x="1828800" y="14977872"/>
-            <a:ext cx="5397246" cy="914400"/>
+            <a:off x="1828800" y="14383512"/>
+            <a:ext cx="8268919" cy="457200"/>
           </a:xfrm>
           <a:prstGeom prst="rect">
             <a:avLst/>
@@ -2534,14 +2535,14 @@
               <a:buNone/>
             </a:pPr>
             <a:r>
-              <a:rPr lang="en-US" sz="2100" dirty="0">
+              <a:rPr lang="en-US" sz="2200" dirty="0">
                 <a:solidFill>
                   <a:schemeClr val="tx2"/>
                 </a:solidFill>
               </a:rPr>
               <a:t>Boeing pays $2.5bn to settle a US fraud charge [5]</a:t>
             </a:r>
-            <a:endParaRPr lang="en-US" sz="2100" dirty="0"/>
+            <a:endParaRPr lang="en-US" sz="2200" dirty="0"/>
           </a:p>
         </p:txBody>
       </p:sp>
@@ -2553,12 +2554,12 @@
         </p:nvSpPr>
         <p:spPr>
           <a:xfrm>
-            <a:off x="1097280" y="16276320"/>
-            <a:ext cx="6128766" cy="2971800"/>
+            <a:off x="1097280" y="15224760"/>
+            <a:ext cx="9000439" cy="1417320"/>
           </a:xfrm>
           <a:prstGeom prst="roundRect">
             <a:avLst>
-              <a:gd name="adj" fmla="val 6154"/>
+              <a:gd name="adj" fmla="val 12903"/>
             </a:avLst>
           </a:prstGeom>
           <a:solidFill>
@@ -2583,7 +2584,7 @@
         </p:blipFill>
         <p:spPr>
           <a:xfrm>
-            <a:off x="1417320" y="17350740"/>
+            <a:off x="1463040" y="15521940"/>
             <a:ext cx="822960" cy="822960"/>
           </a:xfrm>
           <a:prstGeom prst="rect">
@@ -2599,8 +2600,8 @@
         </p:nvSpPr>
         <p:spPr>
           <a:xfrm>
-            <a:off x="2514600" y="16276320"/>
-            <a:ext cx="4437126" cy="2971800"/>
+            <a:off x="2606040" y="15224760"/>
+            <a:ext cx="7217359" cy="1417320"/>
           </a:xfrm>
           <a:prstGeom prst="rect">
             <a:avLst/>
@@ -2648,13 +2649,14 @@
         </p:nvPicPr>
         <p:blipFill>
           <a:blip r:embed="rId3"/>
-          <a:srcRect l="0" r="0" t="0" b="0"/>
-          <a:stretch/>
+          <a:stretch>
+            <a:fillRect/>
+          </a:stretch>
         </p:blipFill>
         <p:spPr>
           <a:xfrm>
-            <a:off x="8414766" y="6675120"/>
-            <a:ext cx="6128766" cy="5486400"/>
+            <a:off x="11286439" y="8001000"/>
+            <a:ext cx="4294480" cy="4480560"/>
           </a:xfrm>
           <a:prstGeom prst="rect">
             <a:avLst/>
@@ -2669,8 +2671,8 @@
         </p:nvSpPr>
         <p:spPr>
           <a:xfrm>
-            <a:off x="8414766" y="12252960"/>
-            <a:ext cx="6128766" cy="457200"/>
+            <a:off x="11286439" y="12573000"/>
+            <a:ext cx="4294480" cy="640080"/>
           </a:xfrm>
           <a:prstGeom prst="rect">
             <a:avLst/>
@@ -2705,8 +2707,8 @@
         </p:nvSpPr>
         <p:spPr>
           <a:xfrm>
-            <a:off x="8414766" y="12847320"/>
-            <a:ext cx="6128766" cy="2743200"/>
+            <a:off x="15992399" y="7955280"/>
+            <a:ext cx="4294480" cy="5212080"/>
           </a:xfrm>
           <a:prstGeom prst="rect">
             <a:avLst/>
@@ -2722,7 +2724,7 @@
               <a:buNone/>
             </a:pPr>
             <a:r>
-              <a:rPr lang="en-US" sz="2500" dirty="0">
+              <a:rPr lang="en-US" sz="2400" dirty="0">
                 <a:solidFill>
                   <a:schemeClr val="tx2"/>
                 </a:solidFill>
@@ -2733,7 +2735,7 @@
               <a:buNone/>
             </a:pPr>
             <a:r>
-              <a:rPr lang="en-US" sz="2500" b="1" dirty="0">
+              <a:rPr lang="en-US" sz="2400" b="1" dirty="0">
                 <a:solidFill>
                   <a:schemeClr val="tx2"/>
                 </a:solidFill>
@@ -2744,7 +2746,7 @@
               <a:buNone/>
             </a:pPr>
             <a:r>
-              <a:rPr lang="en-US" sz="2500" dirty="0">
+              <a:rPr lang="en-US" sz="2400" dirty="0">
                 <a:solidFill>
                   <a:schemeClr val="tx2"/>
                 </a:solidFill>
@@ -2755,7 +2757,7 @@
               <a:buNone/>
             </a:pPr>
             <a:r>
-              <a:rPr lang="en-US" sz="2500" b="1" dirty="0">
+              <a:rPr lang="en-US" sz="2400" b="1" dirty="0">
                 <a:solidFill>
                   <a:schemeClr val="tx2"/>
                 </a:solidFill>
@@ -2766,7 +2768,7 @@
               <a:buNone/>
             </a:pPr>
             <a:r>
-              <a:rPr lang="en-US" sz="2500" dirty="0">
+              <a:rPr lang="en-US" sz="2400" dirty="0">
                 <a:solidFill>
                   <a:schemeClr val="tx2"/>
                 </a:solidFill>
@@ -2777,14 +2779,14 @@
               <a:buNone/>
             </a:pPr>
             <a:r>
-              <a:rPr lang="en-US" sz="2500" b="1" dirty="0">
+              <a:rPr lang="en-US" sz="2400" b="1" dirty="0">
                 <a:solidFill>
                   <a:schemeClr val="tx2"/>
                 </a:solidFill>
               </a:rPr>
               <a:t>pilots wouldn’t need simulator training.</a:t>
             </a:r>
-            <a:endParaRPr lang="en-US" sz="2500" dirty="0"/>
+            <a:endParaRPr lang="en-US" sz="2400" dirty="0"/>
           </a:p>
         </p:txBody>
       </p:sp>
@@ -2796,12 +2798,12 @@
         </p:nvSpPr>
         <p:spPr>
           <a:xfrm>
-            <a:off x="8414766" y="15727680"/>
-            <a:ext cx="6128766" cy="3520440"/>
+            <a:off x="11286439" y="13350240"/>
+            <a:ext cx="9000439" cy="3291840"/>
           </a:xfrm>
           <a:prstGeom prst="roundRect">
             <a:avLst>
-              <a:gd name="adj" fmla="val 5195"/>
+              <a:gd name="adj" fmla="val 5556"/>
             </a:avLst>
           </a:prstGeom>
           <a:solidFill>
@@ -2818,8 +2820,8 @@
         </p:nvSpPr>
         <p:spPr>
           <a:xfrm>
-            <a:off x="8734806" y="16002000"/>
-            <a:ext cx="5580126" cy="2651760"/>
+            <a:off x="11697919" y="13578840"/>
+            <a:ext cx="8268919" cy="2468880"/>
           </a:xfrm>
           <a:prstGeom prst="rect">
             <a:avLst/>
@@ -2838,7 +2840,7 @@
               <a:buNone/>
             </a:pPr>
             <a:r>
-              <a:rPr lang="en-US" sz="2000" dirty="0">
+              <a:rPr lang="en-US" sz="2200" dirty="0">
                 <a:solidFill>
                   <a:srgbClr val="8FB8A8"/>
                 </a:solidFill>
@@ -2848,7 +2850,7 @@
               </a:rPr>
               <a:t>// Simplified illustration</a:t>
             </a:r>
-            <a:endParaRPr lang="en-US" sz="2000" dirty="0"/>
+            <a:endParaRPr lang="en-US" sz="2200" dirty="0"/>
           </a:p>
           <a:p>
             <a:pPr indent="0" marL="0">
@@ -2858,7 +2860,7 @@
               <a:buNone/>
             </a:pPr>
             <a:r>
-              <a:rPr lang="en-US" sz="2000" dirty="0">
+              <a:rPr lang="en-US" sz="2200" dirty="0">
                 <a:solidFill>
                   <a:srgbClr val="FFFFFF"/>
                 </a:solidFill>
@@ -2868,7 +2870,7 @@
               </a:rPr>
               <a:t>if (aoa &gt; LIMIT &amp;&amp; flapsUp)</a:t>
             </a:r>
-            <a:endParaRPr lang="en-US" sz="2000" dirty="0"/>
+            <a:endParaRPr lang="en-US" sz="2200" dirty="0"/>
           </a:p>
           <a:p>
             <a:pPr indent="0" marL="0">
@@ -2878,7 +2880,7 @@
               <a:buNone/>
             </a:pPr>
             <a:r>
-              <a:rPr lang="en-US" sz="2000" dirty="0">
+              <a:rPr lang="en-US" sz="2200" dirty="0">
                 <a:solidFill>
                   <a:srgbClr val="FFFFFF"/>
                 </a:solidFill>
@@ -2886,7 +2888,7 @@
                 <a:ea typeface="Courier New" pitchFamily="34" charset="-122"/>
                 <a:cs typeface="Courier New" pitchFamily="34" charset="-120"/>
               </a:rPr>
-              <a:t>    trimNoseDown(</a:t>
+              <a:t>    trimNoseDown(</a:t>
             </a:r>
             <a:pPr indent="0" marL="0">
               <a:lnSpc>
@@ -2895,7 +2897,7 @@
               <a:buNone/>
             </a:pPr>
             <a:r>
-              <a:rPr lang="en-US" sz="2000" dirty="0">
+              <a:rPr lang="en-US" sz="2200" dirty="0">
                 <a:solidFill>
                   <a:srgbClr val="F2A900"/>
                 </a:solidFill>
@@ -2912,7 +2914,7 @@
               <a:buNone/>
             </a:pPr>
             <a:r>
-              <a:rPr lang="en-US" sz="2000" dirty="0">
+              <a:rPr lang="en-US" sz="2200" dirty="0">
                 <a:solidFill>
                   <a:srgbClr val="8FB8A8"/>
                 </a:solidFill>
@@ -2922,7 +2924,7 @@
               </a:rPr>
               <a:t>);  // degrees</a:t>
             </a:r>
-            <a:endParaRPr lang="en-US" sz="2000" dirty="0"/>
+            <a:endParaRPr lang="en-US" sz="2200" dirty="0"/>
           </a:p>
           <a:p>
             <a:pPr indent="0" marL="0">
@@ -2932,7 +2934,7 @@
               <a:buNone/>
             </a:pPr>
             <a:r>
-              <a:rPr lang="en-US" sz="2000" dirty="0">
+              <a:rPr lang="en-US" sz="2200" dirty="0">
                 <a:solidFill>
                   <a:srgbClr val="8FB8A8"/>
                 </a:solidFill>
@@ -2940,9 +2942,9 @@
                 <a:ea typeface="Courier New" pitchFamily="34" charset="-122"/>
                 <a:cs typeface="Courier New" pitchFamily="34" charset="-120"/>
               </a:rPr>
-              <a:t>    // ...repeats after pilot trims</a:t>
-            </a:r>
-            <a:endParaRPr lang="en-US" sz="2000" dirty="0"/>
+              <a:t>    // ...repeats after pilot trims</a:t>
+            </a:r>
+            <a:endParaRPr lang="en-US" sz="2200" dirty="0"/>
           </a:p>
           <a:p>
             <a:pPr indent="0" marL="0">
@@ -2952,7 +2954,7 @@
               <a:buNone/>
             </a:pPr>
             <a:r>
-              <a:rPr lang="en-US" sz="2000" dirty="0">
+              <a:rPr lang="en-US" sz="2200" dirty="0">
                 <a:solidFill>
                   <a:srgbClr val="FF8A8A"/>
                 </a:solidFill>
@@ -2962,7 +2964,7 @@
               </a:rPr>
               <a:t>// 2nd AoA sensor: never checked</a:t>
             </a:r>
-            <a:endParaRPr lang="en-US" sz="2000" dirty="0"/>
+            <a:endParaRPr lang="en-US" sz="2200" dirty="0"/>
           </a:p>
         </p:txBody>
       </p:sp>
@@ -2974,8 +2976,8 @@
         </p:nvSpPr>
         <p:spPr>
           <a:xfrm>
-            <a:off x="8734806" y="18699480"/>
-            <a:ext cx="5580126" cy="411480"/>
+            <a:off x="11697919" y="16093440"/>
+            <a:ext cx="8268919" cy="411480"/>
           </a:xfrm>
           <a:prstGeom prst="rect">
             <a:avLst/>
@@ -3010,8 +3012,8 @@
         </p:nvSpPr>
         <p:spPr>
           <a:xfrm>
-            <a:off x="15732252" y="6675120"/>
-            <a:ext cx="868680" cy="868680"/>
+            <a:off x="1097280" y="19248120"/>
+            <a:ext cx="822960" cy="822960"/>
           </a:xfrm>
           <a:prstGeom prst="ellipse">
             <a:avLst/>
@@ -3038,8 +3040,8 @@
         </p:blipFill>
         <p:spPr>
           <a:xfrm>
-            <a:off x="15951708" y="6894576"/>
-            <a:ext cx="429768" cy="429768"/>
+            <a:off x="1303020" y="19453860"/>
+            <a:ext cx="411480" cy="411480"/>
           </a:xfrm>
           <a:prstGeom prst="rect">
             <a:avLst/>
@@ -3054,8 +3056,8 @@
         </p:nvSpPr>
         <p:spPr>
           <a:xfrm>
-            <a:off x="16829532" y="6693408"/>
-            <a:ext cx="5031486" cy="457200"/>
+            <a:off x="2103120" y="19266408"/>
+            <a:ext cx="4124410" cy="411480"/>
           </a:xfrm>
           <a:prstGeom prst="rect">
             <a:avLst/>
@@ -3071,14 +3073,14 @@
               <a:buNone/>
             </a:pPr>
             <a:r>
-              <a:rPr lang="en-US" sz="2500" b="1" dirty="0">
+              <a:rPr lang="en-US" sz="2300" b="1" dirty="0">
                 <a:solidFill>
                   <a:schemeClr val="tx1"/>
                 </a:solidFill>
               </a:rPr>
               <a:t>One sensor, no cross-check</a:t>
             </a:r>
-            <a:endParaRPr lang="en-US" sz="2500" dirty="0"/>
+            <a:endParaRPr lang="en-US" sz="2300" dirty="0"/>
           </a:p>
         </p:txBody>
       </p:sp>
@@ -3090,8 +3092,8 @@
         </p:nvSpPr>
         <p:spPr>
           <a:xfrm>
-            <a:off x="16829532" y="7205472"/>
-            <a:ext cx="5031486" cy="1188720"/>
+            <a:off x="2103120" y="19796760"/>
+            <a:ext cx="4124410" cy="1520190"/>
           </a:xfrm>
           <a:prstGeom prst="rect">
             <a:avLst/>
@@ -3126,8 +3128,8 @@
         </p:nvSpPr>
         <p:spPr>
           <a:xfrm>
-            <a:off x="15732252" y="8458200"/>
-            <a:ext cx="868680" cy="868680"/>
+            <a:off x="1097280" y="21408390"/>
+            <a:ext cx="822960" cy="822960"/>
           </a:xfrm>
           <a:prstGeom prst="ellipse">
             <a:avLst/>
@@ -3154,8 +3156,8 @@
         </p:blipFill>
         <p:spPr>
           <a:xfrm>
-            <a:off x="15951708" y="8677656"/>
-            <a:ext cx="429768" cy="429768"/>
+            <a:off x="1303020" y="21614130"/>
+            <a:ext cx="411480" cy="411480"/>
           </a:xfrm>
           <a:prstGeom prst="rect">
             <a:avLst/>
@@ -3170,8 +3172,8 @@
         </p:nvSpPr>
         <p:spPr>
           <a:xfrm>
-            <a:off x="16829532" y="8476488"/>
-            <a:ext cx="5031486" cy="457200"/>
+            <a:off x="2103120" y="21426678"/>
+            <a:ext cx="4124410" cy="411480"/>
           </a:xfrm>
           <a:prstGeom prst="rect">
             <a:avLst/>
@@ -3187,14 +3189,14 @@
               <a:buNone/>
             </a:pPr>
             <a:r>
-              <a:rPr lang="en-US" sz="2500" b="1" dirty="0">
+              <a:rPr lang="en-US" sz="2300" b="1" dirty="0">
                 <a:solidFill>
                   <a:schemeClr val="tx1"/>
                 </a:solidFill>
               </a:rPr>
               <a:t>The limit grew over 4×</a:t>
             </a:r>
-            <a:endParaRPr lang="en-US" sz="2500" dirty="0"/>
+            <a:endParaRPr lang="en-US" sz="2300" dirty="0"/>
           </a:p>
         </p:txBody>
       </p:sp>
@@ -3206,8 +3208,8 @@
         </p:nvSpPr>
         <p:spPr>
           <a:xfrm>
-            <a:off x="16829532" y="8988552"/>
-            <a:ext cx="5031486" cy="1188720"/>
+            <a:off x="2103120" y="21957030"/>
+            <a:ext cx="4124410" cy="1520190"/>
           </a:xfrm>
           <a:prstGeom prst="rect">
             <a:avLst/>
@@ -3236,88 +3238,14 @@
       </p:sp>
       <p:sp>
         <p:nvSpPr>
-          <p:cNvPr id="61" name="Fig3 chart card"/>
+          <p:cNvPr id="61" name="P3 disc 3"/>
           <p:cNvSpPr/>
           <p:nvPr/>
         </p:nvSpPr>
         <p:spPr>
           <a:xfrm>
-            <a:off x="15732252" y="10241280"/>
-            <a:ext cx="6128766" cy="3383280"/>
-          </a:xfrm>
-          <a:prstGeom prst="roundRect">
-            <a:avLst>
-              <a:gd name="adj" fmla="val 5405"/>
-            </a:avLst>
-          </a:prstGeom>
-          <a:solidFill>
-            <a:schemeClr val="bg1"/>
-          </a:solidFill>
-          <a:ln/>
-        </p:spPr>
-      </p:sp>
-      <p:graphicFrame>
-        <p:nvGraphicFramePr>
-          <p:cNvPr id="62" name="Fig3 chart" descr=""/>
-          <p:cNvGraphicFramePr/>
-          <p:nvPr/>
-        </p:nvGraphicFramePr>
-        <p:xfrm>
-          <a:off x="15869412" y="10332720"/>
-          <a:ext cx="5854446" cy="2788920"/>
-        </p:xfrm>
-        <a:graphic xmlns:a="http://schemas.openxmlformats.org/drawingml/2006/main">
-          <a:graphicData uri="http://schemas.openxmlformats.org/drawingml/2006/chart">
-            <c:chart xmlns:c="http://schemas.openxmlformats.org/drawingml/2006/chart" r:id="rId6"/>
-          </a:graphicData>
-        </a:graphic>
-      </p:graphicFrame>
-      <p:sp>
-        <p:nvSpPr>
-          <p:cNvPr id="63" name="Fig3 caption"/>
-          <p:cNvSpPr txBox="1"/>
-          <p:nvPr/>
-        </p:nvSpPr>
-        <p:spPr>
-          <a:xfrm>
-            <a:off x="15960852" y="13167360"/>
-            <a:ext cx="5671566" cy="457200"/>
-          </a:xfrm>
-          <a:prstGeom prst="rect">
-            <a:avLst/>
-          </a:prstGeom>
-          <a:noFill/>
-          <a:ln/>
-        </p:spPr>
-        <p:txBody>
-          <a:bodyPr wrap="square" lIns="0" tIns="0" rIns="0" bIns="0" rtlCol="0" anchor="t"/>
-          <a:lstStyle/>
-          <a:p>
-            <a:pPr indent="0" marL="0">
-              <a:buNone/>
-            </a:pPr>
-            <a:r>
-              <a:rPr lang="en-US" sz="1600" i="1" dirty="0">
-                <a:solidFill>
-                  <a:schemeClr val="accent5"/>
-                </a:solidFill>
-              </a:rPr>
-              <a:t>Fig.3  The limit the FAA saw vs. what flew [2]</a:t>
-            </a:r>
-            <a:endParaRPr lang="en-US" sz="1600" dirty="0"/>
-          </a:p>
-        </p:txBody>
-      </p:sp>
-      <p:sp>
-        <p:nvSpPr>
-          <p:cNvPr id="64" name="P3 disc 3"/>
-          <p:cNvSpPr/>
-          <p:nvPr/>
-        </p:nvSpPr>
-        <p:spPr>
-          <a:xfrm>
-            <a:off x="15732252" y="13944600"/>
-            <a:ext cx="868680" cy="868680"/>
+            <a:off x="1097280" y="23568660"/>
+            <a:ext cx="822960" cy="822960"/>
           </a:xfrm>
           <a:prstGeom prst="ellipse">
             <a:avLst/>
@@ -3330,7 +3258,123 @@
       </p:sp>
       <p:pic>
         <p:nvPicPr>
-          <p:cNvPr id="65" name="P3 icon 3" descr="Pilots weren’t told">    </p:cNvPr>
+          <p:cNvPr id="62" name="P3 icon 3" descr="Pilots weren’t told">    </p:cNvPr>
+          <p:cNvPicPr>
+            <a:picLocks noChangeAspect="1"/>
+          </p:cNvPicPr>
+          <p:nvPr/>
+        </p:nvPicPr>
+        <p:blipFill>
+          <a:blip r:embed="rId6"/>
+          <a:stretch>
+            <a:fillRect/>
+          </a:stretch>
+        </p:blipFill>
+        <p:spPr>
+          <a:xfrm>
+            <a:off x="1303020" y="23774400"/>
+            <a:ext cx="411480" cy="411480"/>
+          </a:xfrm>
+          <a:prstGeom prst="rect">
+            <a:avLst/>
+          </a:prstGeom>
+        </p:spPr>
+      </p:pic>
+      <p:sp>
+        <p:nvSpPr>
+          <p:cNvPr id="63" name="P3 head 3"/>
+          <p:cNvSpPr txBox="1"/>
+          <p:nvPr/>
+        </p:nvSpPr>
+        <p:spPr>
+          <a:xfrm>
+            <a:off x="2103120" y="23586948"/>
+            <a:ext cx="4124410" cy="411480"/>
+          </a:xfrm>
+          <a:prstGeom prst="rect">
+            <a:avLst/>
+          </a:prstGeom>
+          <a:noFill/>
+          <a:ln/>
+        </p:spPr>
+        <p:txBody>
+          <a:bodyPr wrap="square" lIns="0" tIns="0" rIns="0" bIns="0" rtlCol="0" anchor="t"/>
+          <a:lstStyle/>
+          <a:p>
+            <a:pPr indent="0" marL="0">
+              <a:buNone/>
+            </a:pPr>
+            <a:r>
+              <a:rPr lang="en-US" sz="2300" b="1" dirty="0">
+                <a:solidFill>
+                  <a:schemeClr val="tx1"/>
+                </a:solidFill>
+              </a:rPr>
+              <a:t>Pilots weren’t told</a:t>
+            </a:r>
+            <a:endParaRPr lang="en-US" sz="2300" dirty="0"/>
+          </a:p>
+        </p:txBody>
+      </p:sp>
+      <p:sp>
+        <p:nvSpPr>
+          <p:cNvPr id="64" name="P3 text 3"/>
+          <p:cNvSpPr txBox="1"/>
+          <p:nvPr/>
+        </p:nvSpPr>
+        <p:spPr>
+          <a:xfrm>
+            <a:off x="2103120" y="24117300"/>
+            <a:ext cx="4124410" cy="1520190"/>
+          </a:xfrm>
+          <a:prstGeom prst="rect">
+            <a:avLst/>
+          </a:prstGeom>
+          <a:noFill/>
+          <a:ln/>
+        </p:spPr>
+        <p:txBody>
+          <a:bodyPr wrap="square" lIns="0" tIns="0" rIns="0" bIns="0" rtlCol="0" anchor="t"/>
+          <a:lstStyle/>
+          <a:p>
+            <a:pPr indent="0" marL="0">
+              <a:buNone/>
+            </a:pPr>
+            <a:r>
+              <a:rPr lang="en-US" sz="2000" dirty="0">
+                <a:solidFill>
+                  <a:schemeClr val="tx2"/>
+                </a:solidFill>
+              </a:rPr>
+              <a:t>MCAS wasn’t disclosed to pilots, and the ‘AoA disagree’ alert only worked with an optional extra. [3][4]</a:t>
+            </a:r>
+            <a:endParaRPr lang="en-US" sz="2000" dirty="0"/>
+          </a:p>
+        </p:txBody>
+      </p:sp>
+      <p:sp>
+        <p:nvSpPr>
+          <p:cNvPr id="65" name="P3 disc 4"/>
+          <p:cNvSpPr/>
+          <p:nvPr/>
+        </p:nvSpPr>
+        <p:spPr>
+          <a:xfrm>
+            <a:off x="1097280" y="25728930"/>
+            <a:ext cx="822960" cy="822960"/>
+          </a:xfrm>
+          <a:prstGeom prst="ellipse">
+            <a:avLst/>
+          </a:prstGeom>
+          <a:solidFill>
+            <a:schemeClr val="accent1"/>
+          </a:solidFill>
+          <a:ln/>
+        </p:spPr>
+      </p:sp>
+      <p:pic>
+        <p:nvPicPr>
+          <p:cNvPr id="66" name="P3 icon 4" descr="Training was a cost">    </p:cNvPr>
           <p:cNvPicPr>
             <a:picLocks noChangeAspect="1"/>
           </p:cNvPicPr>
@@ -3344,8 +3388,8 @@
         </p:blipFill>
         <p:spPr>
           <a:xfrm>
-            <a:off x="15951708" y="14164056"/>
-            <a:ext cx="429768" cy="429768"/>
+            <a:off x="1303020" y="25934670"/>
+            <a:ext cx="411480" cy="411480"/>
           </a:xfrm>
           <a:prstGeom prst="rect">
             <a:avLst/>
@@ -3354,14 +3398,14 @@
       </p:pic>
       <p:sp>
         <p:nvSpPr>
-          <p:cNvPr id="66" name="P3 head 3"/>
-          <p:cNvSpPr txBox="1"/>
-          <p:nvPr/>
-        </p:nvSpPr>
-        <p:spPr>
-          <a:xfrm>
-            <a:off x="16829532" y="13962888"/>
-            <a:ext cx="5031486" cy="457200"/>
+          <p:cNvPr id="67" name="P3 head 4"/>
+          <p:cNvSpPr txBox="1"/>
+          <p:nvPr/>
+        </p:nvSpPr>
+        <p:spPr>
+          <a:xfrm>
+            <a:off x="2103120" y="25747218"/>
+            <a:ext cx="4124410" cy="411480"/>
           </a:xfrm>
           <a:prstGeom prst="rect">
             <a:avLst/>
@@ -3377,27 +3421,27 @@
               <a:buNone/>
             </a:pPr>
             <a:r>
-              <a:rPr lang="en-US" sz="2500" b="1" dirty="0">
+              <a:rPr lang="en-US" sz="2300" b="1" dirty="0">
                 <a:solidFill>
                   <a:schemeClr val="tx1"/>
                 </a:solidFill>
               </a:rPr>
-              <a:t>Pilots weren’t told</a:t>
-            </a:r>
-            <a:endParaRPr lang="en-US" sz="2500" dirty="0"/>
-          </a:p>
-        </p:txBody>
-      </p:sp>
-      <p:sp>
-        <p:nvSpPr>
-          <p:cNvPr id="67" name="P3 text 3"/>
-          <p:cNvSpPr txBox="1"/>
-          <p:nvPr/>
-        </p:nvSpPr>
-        <p:spPr>
-          <a:xfrm>
-            <a:off x="16829532" y="14474952"/>
-            <a:ext cx="5031486" cy="1188720"/>
+              <a:t>Training was a cost</a:t>
+            </a:r>
+            <a:endParaRPr lang="en-US" sz="2300" dirty="0"/>
+          </a:p>
+        </p:txBody>
+      </p:sp>
+      <p:sp>
+        <p:nvSpPr>
+          <p:cNvPr id="68" name="P3 text 4"/>
+          <p:cNvSpPr txBox="1"/>
+          <p:nvPr/>
+        </p:nvSpPr>
+        <p:spPr>
+          <a:xfrm>
+            <a:off x="2103120" y="26277570"/>
+            <a:ext cx="4124410" cy="1520190"/>
           </a:xfrm>
           <a:prstGeom prst="rect">
             <a:avLst/>
@@ -3418,7 +3462,7 @@
                   <a:schemeClr val="tx2"/>
                 </a:solidFill>
               </a:rPr>
-              <a:t>MCAS wasn’t disclosed to pilots, and the ‘AoA disagree’ alert only worked with an optional extra. [3][4]</a:t>
+              <a:t>Boeing promised Southwest $1M per plane if its pilots needed simulator training. [1]</a:t>
             </a:r>
             <a:endParaRPr lang="en-US" sz="2000" dirty="0"/>
           </a:p>
@@ -3426,58 +3470,52 @@
       </p:sp>
       <p:sp>
         <p:nvSpPr>
-          <p:cNvPr id="68" name="P3 disc 4"/>
+          <p:cNvPr id="69" name="Fig3 chart card"/>
           <p:cNvSpPr/>
           <p:nvPr/>
         </p:nvSpPr>
         <p:spPr>
           <a:xfrm>
-            <a:off x="15732252" y="15727680"/>
-            <a:ext cx="868680" cy="868680"/>
-          </a:xfrm>
-          <a:prstGeom prst="ellipse">
-            <a:avLst/>
-          </a:prstGeom>
-          <a:solidFill>
-            <a:schemeClr val="accent1"/>
-          </a:solidFill>
-          <a:ln/>
-        </p:spPr>
-      </p:sp>
-      <p:pic>
-        <p:nvPicPr>
-          <p:cNvPr id="69" name="P3 icon 4" descr="Training was a cost">    </p:cNvPr>
-          <p:cNvPicPr>
-            <a:picLocks noChangeAspect="1"/>
-          </p:cNvPicPr>
-          <p:nvPr/>
-        </p:nvPicPr>
-        <p:blipFill>
-          <a:blip r:embed="rId8"/>
-          <a:stretch>
-            <a:fillRect/>
-          </a:stretch>
-        </p:blipFill>
-        <p:spPr>
-          <a:xfrm>
-            <a:off x="15951708" y="15947136"/>
-            <a:ext cx="429768" cy="429768"/>
-          </a:xfrm>
-          <a:prstGeom prst="rect">
-            <a:avLst/>
-          </a:prstGeom>
-        </p:spPr>
-      </p:pic>
-      <p:sp>
-        <p:nvSpPr>
-          <p:cNvPr id="70" name="P3 head 4"/>
-          <p:cNvSpPr txBox="1"/>
-          <p:nvPr/>
-        </p:nvSpPr>
-        <p:spPr>
-          <a:xfrm>
-            <a:off x="16829532" y="15745968"/>
-            <a:ext cx="5031486" cy="457200"/>
+            <a:off x="6639010" y="19248120"/>
+            <a:ext cx="3458709" cy="4937760"/>
+          </a:xfrm>
+          <a:prstGeom prst="roundRect">
+            <a:avLst>
+              <a:gd name="adj" fmla="val 5288"/>
+            </a:avLst>
+          </a:prstGeom>
+          <a:solidFill>
+            <a:schemeClr val="bg1"/>
+          </a:solidFill>
+          <a:ln/>
+        </p:spPr>
+      </p:sp>
+      <p:graphicFrame>
+        <p:nvGraphicFramePr>
+          <p:cNvPr id="70" name="Fig3 chart" descr=""/>
+          <p:cNvGraphicFramePr/>
+          <p:nvPr/>
+        </p:nvGraphicFramePr>
+        <p:xfrm>
+          <a:off x="6776170" y="19385280"/>
+          <a:ext cx="3184389" cy="4069080"/>
+        </p:xfrm>
+        <a:graphic xmlns:a="http://schemas.openxmlformats.org/drawingml/2006/main">
+          <a:graphicData uri="http://schemas.openxmlformats.org/drawingml/2006/chart">
+            <c:chart xmlns:c="http://schemas.openxmlformats.org/drawingml/2006/chart" r:id="rId8"/>
+          </a:graphicData>
+        </a:graphic>
+      </p:graphicFrame>
+      <p:sp>
+        <p:nvSpPr>
+          <p:cNvPr id="71" name="Fig3 caption"/>
+          <p:cNvSpPr txBox="1"/>
+          <p:nvPr/>
+        </p:nvSpPr>
+        <p:spPr>
+          <a:xfrm>
+            <a:off x="6867610" y="23500080"/>
+            <a:ext cx="3001509" cy="548640"/>
           </a:xfrm>
           <a:prstGeom prst="rect">
             <a:avLst/>
@@ -3493,50 +3531,14 @@
               <a:buNone/>
             </a:pPr>
             <a:r>
-              <a:rPr lang="en-US" sz="2500" b="1" dirty="0">
-                <a:solidFill>
-                  <a:schemeClr val="tx1"/>
-                </a:solidFill>
-              </a:rPr>
-              <a:t>Training was a cost</a:t>
-            </a:r>
-            <a:endParaRPr lang="en-US" sz="2500" dirty="0"/>
-          </a:p>
-        </p:txBody>
-      </p:sp>
-      <p:sp>
-        <p:nvSpPr>
-          <p:cNvPr id="71" name="P3 text 4"/>
-          <p:cNvSpPr txBox="1"/>
-          <p:nvPr/>
-        </p:nvSpPr>
-        <p:spPr>
-          <a:xfrm>
-            <a:off x="16829532" y="16258032"/>
-            <a:ext cx="5031486" cy="1188720"/>
-          </a:xfrm>
-          <a:prstGeom prst="rect">
-            <a:avLst/>
-          </a:prstGeom>
-          <a:noFill/>
-          <a:ln/>
-        </p:spPr>
-        <p:txBody>
-          <a:bodyPr wrap="square" lIns="0" tIns="0" rIns="0" bIns="0" rtlCol="0" anchor="t"/>
-          <a:lstStyle/>
-          <a:p>
-            <a:pPr indent="0" marL="0">
-              <a:buNone/>
-            </a:pPr>
-            <a:r>
-              <a:rPr lang="en-US" sz="2000" dirty="0">
-                <a:solidFill>
-                  <a:schemeClr val="tx2"/>
-                </a:solidFill>
-              </a:rPr>
-              <a:t>Boeing promised Southwest $1M per plane if its pilots needed simulator training. [1]</a:t>
-            </a:r>
-            <a:endParaRPr lang="en-US" sz="2000" dirty="0"/>
+              <a:rPr lang="en-US" sz="1500" i="1" dirty="0">
+                <a:solidFill>
+                  <a:schemeClr val="accent5"/>
+                </a:solidFill>
+              </a:rPr>
+              <a:t>Fig.3  The limit the FAA saw vs. what flew [2]</a:t>
+            </a:r>
+            <a:endParaRPr lang="en-US" sz="1500" dirty="0"/>
           </a:p>
         </p:txBody>
       </p:sp>
@@ -3548,12 +3550,12 @@
         </p:nvSpPr>
         <p:spPr>
           <a:xfrm>
-            <a:off x="15732252" y="17556480"/>
-            <a:ext cx="6128766" cy="1691640"/>
+            <a:off x="6639010" y="24551640"/>
+            <a:ext cx="3458709" cy="3337560"/>
           </a:xfrm>
           <a:prstGeom prst="roundRect">
             <a:avLst>
-              <a:gd name="adj" fmla="val 10811"/>
+              <a:gd name="adj" fmla="val 5479"/>
             </a:avLst>
           </a:prstGeom>
           <a:solidFill>
@@ -3570,8 +3572,8 @@
         </p:nvSpPr>
         <p:spPr>
           <a:xfrm>
-            <a:off x="16052292" y="17556480"/>
-            <a:ext cx="5488686" cy="1691640"/>
+            <a:off x="7004770" y="24551640"/>
+            <a:ext cx="2727189" cy="3337560"/>
           </a:xfrm>
           <a:prstGeom prst="rect">
             <a:avLst/>
@@ -3587,14 +3589,14 @@
               <a:buNone/>
             </a:pPr>
             <a:r>
-              <a:rPr lang="en-US" sz="2400" b="1" dirty="0">
+              <a:rPr lang="en-US" sz="2600" b="1" dirty="0">
                 <a:solidFill>
                   <a:schemeClr val="bg1"/>
                 </a:solidFill>
               </a:rPr>
               <a:t>Not a bug: the code did exactly what it was designed to do.</a:t>
             </a:r>
-            <a:endParaRPr lang="en-US" sz="2400" dirty="0"/>
+            <a:endParaRPr lang="en-US" sz="2600" dirty="0"/>
           </a:p>
         </p:txBody>
       </p:sp>
@@ -3608,13 +3610,14 @@
         </p:nvPicPr>
         <p:blipFill>
           <a:blip r:embed="rId9"/>
-          <a:srcRect l="0" r="0" t="0" b="0"/>
-          <a:stretch/>
+          <a:stretch>
+            <a:fillRect/>
+          </a:stretch>
         </p:blipFill>
         <p:spPr>
           <a:xfrm>
-            <a:off x="23049738" y="6675120"/>
-            <a:ext cx="6128766" cy="4572000"/>
+            <a:off x="11286439" y="19248120"/>
+            <a:ext cx="4294480" cy="4206240"/>
           </a:xfrm>
           <a:prstGeom prst="rect">
             <a:avLst/>
@@ -3629,8 +3632,8 @@
         </p:nvSpPr>
         <p:spPr>
           <a:xfrm>
-            <a:off x="23049738" y="11338560"/>
-            <a:ext cx="6128766" cy="457200"/>
+            <a:off x="11286439" y="23545800"/>
+            <a:ext cx="4294480" cy="640080"/>
           </a:xfrm>
           <a:prstGeom prst="rect">
             <a:avLst/>
@@ -3665,8 +3668,8 @@
         </p:nvSpPr>
         <p:spPr>
           <a:xfrm>
-            <a:off x="23049738" y="11978640"/>
-            <a:ext cx="6128766" cy="3017520"/>
+            <a:off x="15992399" y="19202400"/>
+            <a:ext cx="4294480" cy="5029200"/>
           </a:xfrm>
           <a:prstGeom prst="rect">
             <a:avLst/>
@@ -3721,8 +3724,8 @@
         </p:nvSpPr>
         <p:spPr>
           <a:xfrm>
-            <a:off x="23049738" y="15133320"/>
-            <a:ext cx="6128766" cy="502920"/>
+            <a:off x="11286439" y="24368760"/>
+            <a:ext cx="9000439" cy="548640"/>
           </a:xfrm>
           <a:prstGeom prst="rect">
             <a:avLst/>
@@ -3738,14 +3741,14 @@
               <a:buNone/>
             </a:pPr>
             <a:r>
-              <a:rPr lang="en-US" sz="2600" b="1" dirty="0">
+              <a:rPr lang="en-US" sz="2800" b="1" dirty="0">
                 <a:solidFill>
                   <a:schemeClr val="accent4"/>
                 </a:solidFill>
               </a:rPr>
               <a:t>Ask yourself:</a:t>
             </a:r>
-            <a:endParaRPr lang="en-US" sz="2600" dirty="0"/>
+            <a:endParaRPr lang="en-US" sz="2800" dirty="0"/>
           </a:p>
         </p:txBody>
       </p:sp>
@@ -3757,8 +3760,8 @@
         </p:nvSpPr>
         <p:spPr>
           <a:xfrm>
-            <a:off x="23049738" y="15773400"/>
-            <a:ext cx="6128766" cy="3474720"/>
+            <a:off x="11286439" y="25054560"/>
+            <a:ext cx="9000439" cy="2834640"/>
           </a:xfrm>
           <a:prstGeom prst="rect">
             <a:avLst/>
@@ -3772,56 +3775,56 @@
           <a:p>
             <a:pPr marL="342900" indent="-342900">
               <a:spcAft>
-                <a:spcPts val="1400"/>
+                <a:spcPts val="1200"/>
               </a:spcAft>
               <a:buSzPct val="100000"/>
               <a:buChar char="•"/>
             </a:pPr>
             <a:r>
-              <a:rPr lang="en-US" sz="2400" b="1" dirty="0">
+              <a:rPr lang="en-US" sz="2500" b="1" dirty="0">
                 <a:solidFill>
                   <a:schemeClr val="tx1"/>
                 </a:solidFill>
               </a:rPr>
               <a:t>Would you ship a safety feature that trusts one sensor?</a:t>
             </a:r>
-            <a:endParaRPr lang="en-US" sz="2400" dirty="0"/>
+            <a:endParaRPr lang="en-US" sz="2500" dirty="0"/>
           </a:p>
           <a:p>
             <a:pPr marL="342900" indent="-342900">
               <a:spcAft>
-                <a:spcPts val="1400"/>
+                <a:spcPts val="1200"/>
               </a:spcAft>
               <a:buSzPct val="100000"/>
               <a:buChar char="•"/>
             </a:pPr>
             <a:r>
-              <a:rPr lang="en-US" sz="2400" b="1" dirty="0">
+              <a:rPr lang="en-US" sz="2500" b="1" dirty="0">
                 <a:solidFill>
                   <a:schemeClr val="tx1"/>
                 </a:solidFill>
               </a:rPr>
               <a:t>When the requirement changes, does the safety analysis?</a:t>
             </a:r>
-            <a:endParaRPr lang="en-US" sz="2400" dirty="0"/>
+            <a:endParaRPr lang="en-US" sz="2500" dirty="0"/>
           </a:p>
           <a:p>
             <a:pPr marL="342900" indent="-342900">
               <a:spcAft>
-                <a:spcPts val="1400"/>
+                <a:spcPts val="1200"/>
               </a:spcAft>
               <a:buSzPct val="100000"/>
               <a:buChar char="•"/>
             </a:pPr>
             <a:r>
-              <a:rPr lang="en-US" sz="2400" b="1" dirty="0">
+              <a:rPr lang="en-US" sz="2500" b="1" dirty="0">
                 <a:solidFill>
                   <a:schemeClr val="tx1"/>
                 </a:solidFill>
               </a:rPr>
               <a:t>If users don’t know your code exists, how can they fight it?</a:t>
             </a:r>
-            <a:endParaRPr lang="en-US" sz="2400" dirty="0"/>
+            <a:endParaRPr lang="en-US" sz="2500" dirty="0"/>
           </a:p>
         </p:txBody>
       </p:sp>
@@ -3833,7 +3836,7 @@
         </p:nvSpPr>
         <p:spPr>
           <a:xfrm>
-            <a:off x="731520" y="19888200"/>
+            <a:off x="731520" y="28483560"/>
             <a:ext cx="3657600" cy="365760"/>
           </a:xfrm>
           <a:prstGeom prst="rect">
@@ -3869,8 +3872,8 @@
         </p:nvSpPr>
         <p:spPr>
           <a:xfrm>
-            <a:off x="731520" y="20299680"/>
-            <a:ext cx="14132052" cy="1188720"/>
+            <a:off x="731520" y="28895040"/>
+            <a:ext cx="9686239" cy="1371600"/>
           </a:xfrm>
           <a:prstGeom prst="rect">
             <a:avLst/>
@@ -3886,42 +3889,42 @@
               <a:buNone/>
             </a:pPr>
             <a:r>
-              <a:rPr lang="en-US" sz="1400" dirty="0">
+              <a:rPr lang="en-US" sz="1300" dirty="0">
                 <a:solidFill>
                   <a:schemeClr val="tx2"/>
                 </a:solidFill>
               </a:rPr>
               <a:t>[1] US House Committee on Transportation and Infrastructure (2020) Final Committee Report: The Design, Development &amp; Certification of the Boeing 737 MAX. September 2020.</a:t>
             </a:r>
-            <a:endParaRPr lang="en-US" sz="1400" dirty="0"/>
-          </a:p>
-          <a:p>
-            <a:pPr indent="0" marL="0">
-              <a:buNone/>
-            </a:pPr>
-            <a:r>
-              <a:rPr lang="en-US" sz="1400" dirty="0">
+            <a:endParaRPr lang="en-US" sz="1300" dirty="0"/>
+          </a:p>
+          <a:p>
+            <a:pPr indent="0" marL="0">
+              <a:buNone/>
+            </a:pPr>
+            <a:r>
+              <a:rPr lang="en-US" sz="1300" dirty="0">
                 <a:solidFill>
                   <a:schemeClr val="tx2"/>
                 </a:solidFill>
               </a:rPr>
               <a:t>[2] Gates, D. (2019) Flawed analysis, failed oversight: How Boeing, FAA certified the suspect 737 MAX flight control system. The Seattle Times, 17 March 2019.</a:t>
             </a:r>
-            <a:endParaRPr lang="en-US" sz="1400" dirty="0"/>
-          </a:p>
-          <a:p>
-            <a:pPr indent="0" marL="0">
-              <a:buNone/>
-            </a:pPr>
-            <a:r>
-              <a:rPr lang="en-US" sz="1400" dirty="0">
+            <a:endParaRPr lang="en-US" sz="1300" dirty="0"/>
+          </a:p>
+          <a:p>
+            <a:pPr indent="0" marL="0">
+              <a:buNone/>
+            </a:pPr>
+            <a:r>
+              <a:rPr lang="en-US" sz="1300" dirty="0">
                 <a:solidFill>
                   <a:schemeClr val="tx2"/>
                 </a:solidFill>
               </a:rPr>
               <a:t>[3] CNBC (2018) Optional warning light could have aided Lion Air before crash. CNBC, 30 November 2018.</a:t>
             </a:r>
-            <a:endParaRPr lang="en-US" sz="1400" dirty="0"/>
+            <a:endParaRPr lang="en-US" sz="1300" dirty="0"/>
           </a:p>
         </p:txBody>
       </p:sp>
@@ -3933,8 +3936,8 @@
         </p:nvSpPr>
         <p:spPr>
           <a:xfrm>
-            <a:off x="15412212" y="20299680"/>
-            <a:ext cx="14132052" cy="1188720"/>
+            <a:off x="10966399" y="28895040"/>
+            <a:ext cx="9686239" cy="1371600"/>
           </a:xfrm>
           <a:prstGeom prst="rect">
             <a:avLst/>
@@ -3950,42 +3953,42 @@
               <a:buNone/>
             </a:pPr>
             <a:r>
-              <a:rPr lang="en-US" sz="1400" dirty="0">
+              <a:rPr lang="en-US" sz="1300" dirty="0">
                 <a:solidFill>
                   <a:schemeClr val="tx2"/>
                 </a:solidFill>
               </a:rPr>
               <a:t>[4] Associated Press (2025) Timeline: Key events in the troubled history of the Boeing 737 Max jetliner. AP, September 2025.</a:t>
             </a:r>
-            <a:endParaRPr lang="en-US" sz="1400" dirty="0"/>
-          </a:p>
-          <a:p>
-            <a:pPr indent="0" marL="0">
-              <a:buNone/>
-            </a:pPr>
-            <a:r>
-              <a:rPr lang="en-US" sz="1400" dirty="0">
+            <a:endParaRPr lang="en-US" sz="1300" dirty="0"/>
+          </a:p>
+          <a:p>
+            <a:pPr indent="0" marL="0">
+              <a:buNone/>
+            </a:pPr>
+            <a:r>
+              <a:rPr lang="en-US" sz="1300" dirty="0">
                 <a:solidFill>
                   <a:schemeClr val="tx2"/>
                 </a:solidFill>
               </a:rPr>
               <a:t>[5] Reuters (2021) Boeing pays $2.5bn to settle US fraud charge over 737 MAX. Published via BusinessLIVE, 8 January 2021.</a:t>
             </a:r>
-            <a:endParaRPr lang="en-US" sz="1400" dirty="0"/>
-          </a:p>
-          <a:p>
-            <a:pPr indent="0" marL="0">
-              <a:buNone/>
-            </a:pPr>
-            <a:r>
-              <a:rPr lang="en-US" sz="1400" dirty="0">
+            <a:endParaRPr lang="en-US" sz="1300" dirty="0"/>
+          </a:p>
+          <a:p>
+            <a:pPr indent="0" marL="0">
+              <a:buNone/>
+            </a:pPr>
+            <a:r>
+              <a:rPr lang="en-US" sz="1300" dirty="0">
                 <a:solidFill>
                   <a:schemeClr val="tx2"/>
                 </a:solidFill>
               </a:rPr>
               <a:t>Photos: [add the source of each photo].   Icons: Font Awesome Free (CC BY 4.0).</a:t>
             </a:r>
-            <a:endParaRPr lang="en-US" sz="1400" dirty="0"/>
+            <a:endParaRPr lang="en-US" sz="1300" dirty="0"/>
           </a:p>
         </p:txBody>
       </p:sp>

</xml_diff>

<commit_message>
Argue MCAS was a bug: it matched the spec but not the intent
Updates the video script's answer and closing line, and the poster's red
callout, so both make the same argument.

Co-Authored-By: Claude Opus 5.5 <noreply@anthropic.com>
Claude-Session: https://claude.ai/code/session_01E3rJRgKZxEHSV1mKDFw6wE
</commit_message>
<xml_diff>
--- a/boeing-737-max-example/Poster - Boeing 737 MAX.pptx
+++ b/boeing-737-max-example/Poster - Boeing 737 MAX.pptx
@@ -107,7 +107,7 @@
   <p:extLst>
     <p:ext uri="{521415D9-36F7-43E2-AB2F-B90AF26B5E84}">
       <p14:sectionLst xmlns:p14="http://schemas.microsoft.com/office/powerpoint/2010/main">
-        <p14:section name="Poster" id="{61ced7dc-ef0c-bee5-88d1-d39fef6f30ad}">
+        <p14:section name="Poster" id="{fa60ee3e-5e76-8ac8-4f40-dc8cfb762e0a}">
           <p14:sldIdLst>
             <p14:sldId id="256"/>
           </p14:sldIdLst>
@@ -3947,7 +3947,7 @@
                   <a:schemeClr val="bg1"/>
                 </a:solidFill>
               </a:rPr>
-              <a:t>Not a bug: the code did exactly what it was designed to do.</a:t>
+              <a:t>Still a bug: it matched the spec, but not what anyone intended.</a:t>
             </a:r>
             <a:endParaRPr lang="en-US" sz="2500" dirty="0"/>
           </a:p>

</xml_diff>